<commit_message>
update : ajout changement de AgaMoon
</commit_message>
<xml_diff>
--- a/MoonWebsite/annexe/Presentation.pptx
+++ b/MoonWebsite/annexe/Presentation.pptx
@@ -4813,11 +4813,7 @@
           <a:p>
             <a:r>
               <a:rPr lang="fr-CH" dirty="0"/>
-              <a:t>Faire un projet avec </a:t>
-            </a:r>
-            <a:r>
-              <a:rPr lang="fr-CH"/>
-              <a:t>des calculs</a:t>
+              <a:t>Faire un projet avec des calculs</a:t>
             </a:r>
           </a:p>
         </p:txBody>

</xml_diff>